<commit_message>
Generate and verify M04 classroom artifacts
Co-authored-by: shaseaver25 <shannon@tailoredu.org>
</commit_message>
<xml_diff>
--- a/teaching-pack/04-M03-hallucination/M03-slides-hallucination.pptx
+++ b/teaching-pack/04-M03-hallucination/M03-slides-hallucination.pptx
@@ -10329,8 +10329,8 @@
         </p:blipFill>
         <p:spPr>
           <a:xfrm>
-            <a:off x="3023044" y="1883664"/>
-            <a:ext cx="6145607" cy="3383280"/>
+            <a:off x="3069766" y="1883664"/>
+            <a:ext cx="6052162" cy="3383280"/>
           </a:xfrm>
           <a:prstGeom prst="rect">
             <a:avLst/>

</xml_diff>

<commit_message>
Exclude unrelated regenerated artifacts
Co-authored-by: shaseaver25 <shannon@tailoredu.org>
</commit_message>
<xml_diff>
--- a/teaching-pack/04-M03-hallucination/M03-slides-hallucination.pptx
+++ b/teaching-pack/04-M03-hallucination/M03-slides-hallucination.pptx
@@ -10329,8 +10329,8 @@
         </p:blipFill>
         <p:spPr>
           <a:xfrm>
-            <a:off x="3069766" y="1883664"/>
-            <a:ext cx="6052162" cy="3383280"/>
+            <a:off x="3023044" y="1883664"/>
+            <a:ext cx="6145607" cy="3383280"/>
           </a:xfrm>
           <a:prstGeom prst="rect">
             <a:avLst/>

</xml_diff>